<commit_message>
Update proposal deck to v6 and archive earlier versions
</commit_message>
<xml_diff>
--- a/deck/PhD_Proposal_ZaVinhLe_v5.pptx
+++ b/deck/PhD_Proposal_ZaVinhLe_v5.pptx
@@ -2317,7 +2317,7 @@
           </a:prstGeom>
           <a:extLst>
             <a:ext uri="{C572A759-6A51-4108-AA02-DFA0A04FC94B}">
-              <ma14:wrappingTextBoxFlag xmlns="" xmlns:ma14="http://schemas.microsoft.com/office/mac/drawingml/2011/main" val="0"/>
+              <ma14:wrappingTextBoxFlag xmlns:ma14="http://schemas.microsoft.com/office/mac/drawingml/2011/main" xmlns="" val="0"/>
             </a:ext>
           </a:extLst>
         </p:spPr>
@@ -2395,7 +2395,7 @@
           </a:prstGeom>
           <a:extLst>
             <a:ext uri="{C572A759-6A51-4108-AA02-DFA0A04FC94B}">
-              <ma14:wrappingTextBoxFlag xmlns="" xmlns:ma14="http://schemas.microsoft.com/office/mac/drawingml/2011/main" val="0"/>
+              <ma14:wrappingTextBoxFlag xmlns:ma14="http://schemas.microsoft.com/office/mac/drawingml/2011/main" xmlns="" val="0"/>
             </a:ext>
           </a:extLst>
         </p:spPr>
@@ -4302,7 +4302,7 @@
           </a:prstGeom>
           <a:extLst>
             <a:ext uri="{C572A759-6A51-4108-AA02-DFA0A04FC94B}">
-              <ma14:wrappingTextBoxFlag xmlns="" xmlns:ma14="http://schemas.microsoft.com/office/mac/drawingml/2011/main" val="0"/>
+              <ma14:wrappingTextBoxFlag xmlns:ma14="http://schemas.microsoft.com/office/mac/drawingml/2011/main" xmlns="" val="0"/>
             </a:ext>
           </a:extLst>
         </p:spPr>
@@ -5117,7 +5117,7 @@
           </a:prstGeom>
           <a:extLst>
             <a:ext uri="{C572A759-6A51-4108-AA02-DFA0A04FC94B}">
-              <ma14:wrappingTextBoxFlag xmlns="" xmlns:ma14="http://schemas.microsoft.com/office/mac/drawingml/2011/main" val="0"/>
+              <ma14:wrappingTextBoxFlag xmlns:ma14="http://schemas.microsoft.com/office/mac/drawingml/2011/main" xmlns="" val="0"/>
             </a:ext>
           </a:extLst>
         </p:spPr>
@@ -6469,7 +6469,7 @@
           </a:prstGeom>
           <a:extLst>
             <a:ext uri="{C572A759-6A51-4108-AA02-DFA0A04FC94B}">
-              <ma14:wrappingTextBoxFlag xmlns="" xmlns:ma14="http://schemas.microsoft.com/office/mac/drawingml/2011/main" val="0"/>
+              <ma14:wrappingTextBoxFlag xmlns:ma14="http://schemas.microsoft.com/office/mac/drawingml/2011/main" xmlns="" val="0"/>
             </a:ext>
           </a:extLst>
         </p:spPr>
@@ -7395,7 +7395,7 @@
           </a:prstGeom>
           <a:extLst>
             <a:ext uri="{C572A759-6A51-4108-AA02-DFA0A04FC94B}">
-              <ma14:wrappingTextBoxFlag xmlns="" xmlns:ma14="http://schemas.microsoft.com/office/mac/drawingml/2011/main" val="0"/>
+              <ma14:wrappingTextBoxFlag xmlns:ma14="http://schemas.microsoft.com/office/mac/drawingml/2011/main" xmlns="" val="0"/>
             </a:ext>
           </a:extLst>
         </p:spPr>
@@ -8918,7 +8918,7 @@
           </a:prstGeom>
           <a:extLst>
             <a:ext uri="{C572A759-6A51-4108-AA02-DFA0A04FC94B}">
-              <ma14:wrappingTextBoxFlag xmlns="" xmlns:ma14="http://schemas.microsoft.com/office/mac/drawingml/2011/main" val="0"/>
+              <ma14:wrappingTextBoxFlag xmlns:ma14="http://schemas.microsoft.com/office/mac/drawingml/2011/main" xmlns="" val="0"/>
             </a:ext>
           </a:extLst>
         </p:spPr>
@@ -9963,7 +9963,7 @@
           </a:prstGeom>
           <a:extLst>
             <a:ext uri="{C572A759-6A51-4108-AA02-DFA0A04FC94B}">
-              <ma14:wrappingTextBoxFlag xmlns="" xmlns:ma14="http://schemas.microsoft.com/office/mac/drawingml/2011/main" val="0"/>
+              <ma14:wrappingTextBoxFlag xmlns:ma14="http://schemas.microsoft.com/office/mac/drawingml/2011/main" xmlns="" val="0"/>
             </a:ext>
           </a:extLst>
         </p:spPr>
@@ -11993,7 +11993,7 @@
           </a:prstGeom>
           <a:extLst>
             <a:ext uri="{C572A759-6A51-4108-AA02-DFA0A04FC94B}">
-              <ma14:wrappingTextBoxFlag xmlns="" xmlns:ma14="http://schemas.microsoft.com/office/mac/drawingml/2011/main" val="0"/>
+              <ma14:wrappingTextBoxFlag xmlns:ma14="http://schemas.microsoft.com/office/mac/drawingml/2011/main" xmlns="" val="0"/>
             </a:ext>
           </a:extLst>
         </p:spPr>
@@ -13108,7 +13108,7 @@
           </a:prstGeom>
           <a:extLst>
             <a:ext uri="{C572A759-6A51-4108-AA02-DFA0A04FC94B}">
-              <ma14:wrappingTextBoxFlag xmlns="" xmlns:ma14="http://schemas.microsoft.com/office/mac/drawingml/2011/main" val="0"/>
+              <ma14:wrappingTextBoxFlag xmlns:ma14="http://schemas.microsoft.com/office/mac/drawingml/2011/main" xmlns="" val="0"/>
             </a:ext>
           </a:extLst>
         </p:spPr>
@@ -13537,7 +13537,7 @@
           </a:prstGeom>
           <a:extLst>
             <a:ext uri="{C572A759-6A51-4108-AA02-DFA0A04FC94B}">
-              <ma14:wrappingTextBoxFlag xmlns="" xmlns:ma14="http://schemas.microsoft.com/office/mac/drawingml/2011/main" val="0"/>
+              <ma14:wrappingTextBoxFlag xmlns:ma14="http://schemas.microsoft.com/office/mac/drawingml/2011/main" xmlns="" val="0"/>
             </a:ext>
           </a:extLst>
         </p:spPr>
@@ -13666,7 +13666,7 @@
                 <a:ea typeface="Cambria" pitchFamily="34" charset="-122"/>
                 <a:cs typeface="Cambria" pitchFamily="34" charset="-120"/>
               </a:rPr>
-              <a:t>Turning specifications into tests by hand does not scale</a:t>
+              <a:t>Write tests manually does not scale</a:t>
             </a:r>
             <a:endParaRPr lang="en-US" sz="3000" dirty="0"/>
           </a:p>
@@ -14716,7 +14716,7 @@
           </a:prstGeom>
           <a:extLst>
             <a:ext uri="{C572A759-6A51-4108-AA02-DFA0A04FC94B}">
-              <ma14:wrappingTextBoxFlag xmlns:ma14="http://schemas.microsoft.com/office/mac/drawingml/2011/main" xmlns="" val="0"/>
+              <ma14:wrappingTextBoxFlag xmlns="" xmlns:ma14="http://schemas.microsoft.com/office/mac/drawingml/2011/main" val="0"/>
             </a:ext>
           </a:extLst>
         </p:spPr>
@@ -15174,7 +15174,7 @@
           </a:prstGeom>
           <a:extLst>
             <a:ext uri="{C572A759-6A51-4108-AA02-DFA0A04FC94B}">
-              <ma14:wrappingTextBoxFlag xmlns="" xmlns:ma14="http://schemas.microsoft.com/office/mac/drawingml/2011/main" val="0"/>
+              <ma14:wrappingTextBoxFlag xmlns:ma14="http://schemas.microsoft.com/office/mac/drawingml/2011/main" xmlns="" val="0"/>
             </a:ext>
           </a:extLst>
         </p:spPr>
@@ -15632,7 +15632,7 @@
           </a:prstGeom>
           <a:extLst>
             <a:ext uri="{C572A759-6A51-4108-AA02-DFA0A04FC94B}">
-              <ma14:wrappingTextBoxFlag xmlns="" xmlns:ma14="http://schemas.microsoft.com/office/mac/drawingml/2011/main" val="0"/>
+              <ma14:wrappingTextBoxFlag xmlns:ma14="http://schemas.microsoft.com/office/mac/drawingml/2011/main" xmlns="" val="0"/>
             </a:ext>
           </a:extLst>
         </p:spPr>
@@ -16848,7 +16848,7 @@
           </a:prstGeom>
           <a:extLst>
             <a:ext uri="{C572A759-6A51-4108-AA02-DFA0A04FC94B}">
-              <ma14:wrappingTextBoxFlag xmlns:ma14="http://schemas.microsoft.com/office/mac/drawingml/2011/main" xmlns="" val="0"/>
+              <ma14:wrappingTextBoxFlag xmlns="" xmlns:ma14="http://schemas.microsoft.com/office/mac/drawingml/2011/main" val="0"/>
             </a:ext>
           </a:extLst>
         </p:spPr>
@@ -17635,7 +17635,7 @@
           </a:prstGeom>
           <a:extLst>
             <a:ext uri="{C572A759-6A51-4108-AA02-DFA0A04FC94B}">
-              <ma14:wrappingTextBoxFlag xmlns="" xmlns:ma14="http://schemas.microsoft.com/office/mac/drawingml/2011/main" val="0"/>
+              <ma14:wrappingTextBoxFlag xmlns:ma14="http://schemas.microsoft.com/office/mac/drawingml/2011/main" xmlns="" val="0"/>
             </a:ext>
           </a:extLst>
         </p:spPr>
@@ -19814,7 +19814,7 @@
           </a:prstGeom>
           <a:extLst>
             <a:ext uri="{C572A759-6A51-4108-AA02-DFA0A04FC94B}">
-              <ma14:wrappingTextBoxFlag xmlns="" xmlns:ma14="http://schemas.microsoft.com/office/mac/drawingml/2011/main" val="0"/>
+              <ma14:wrappingTextBoxFlag xmlns:ma14="http://schemas.microsoft.com/office/mac/drawingml/2011/main" xmlns="" val="0"/>
             </a:ext>
           </a:extLst>
         </p:spPr>
@@ -21506,7 +21506,7 @@
           </a:prstGeom>
           <a:extLst>
             <a:ext uri="{C572A759-6A51-4108-AA02-DFA0A04FC94B}">
-              <ma14:wrappingTextBoxFlag xmlns="" xmlns:ma14="http://schemas.microsoft.com/office/mac/drawingml/2011/main" val="0"/>
+              <ma14:wrappingTextBoxFlag xmlns:ma14="http://schemas.microsoft.com/office/mac/drawingml/2011/main" xmlns="" val="0"/>
             </a:ext>
           </a:extLst>
         </p:spPr>
@@ -22411,7 +22411,7 @@
           </a:prstGeom>
           <a:extLst>
             <a:ext uri="{C572A759-6A51-4108-AA02-DFA0A04FC94B}">
-              <ma14:wrappingTextBoxFlag xmlns="" xmlns:ma14="http://schemas.microsoft.com/office/mac/drawingml/2011/main" val="0"/>
+              <ma14:wrappingTextBoxFlag xmlns:ma14="http://schemas.microsoft.com/office/mac/drawingml/2011/main" xmlns="" val="0"/>
             </a:ext>
           </a:extLst>
         </p:spPr>
@@ -23433,7 +23433,7 @@
           </a:prstGeom>
           <a:extLst>
             <a:ext uri="{C572A759-6A51-4108-AA02-DFA0A04FC94B}">
-              <ma14:wrappingTextBoxFlag xmlns="" xmlns:ma14="http://schemas.microsoft.com/office/mac/drawingml/2011/main" val="0"/>
+              <ma14:wrappingTextBoxFlag xmlns:ma14="http://schemas.microsoft.com/office/mac/drawingml/2011/main" xmlns="" val="0"/>
             </a:ext>
           </a:extLst>
         </p:spPr>

</xml_diff>